<commit_message>
Add landing page (Russian), Dockerfile + docker-compose, Lipinski Rule-of-Five filter, color-coded results
</commit_message>
<xml_diff>
--- a/promo/ADMET_Predictor_Executive_Summary.pptx
+++ b/promo/ADMET_Predictor_Executive_Summary.pptx
@@ -5,14 +5,14 @@
     <p:sldMasterId id="2147483648" r:id="rId1"/>
   </p:sldMasterIdLst>
   <p:sldIdLst>
-    <p:sldId id="256" r:id="rId7"/>
-    <p:sldId id="257" r:id="rId8"/>
-    <p:sldId id="258" r:id="rId9"/>
-    <p:sldId id="259" r:id="rId10"/>
-    <p:sldId id="260" r:id="rId11"/>
-    <p:sldId id="261" r:id="rId12"/>
+    <p:sldId id="256" r:id="rId2"/>
+    <p:sldId id="257" r:id="rId3"/>
+    <p:sldId id="258" r:id="rId4"/>
+    <p:sldId id="259" r:id="rId5"/>
+    <p:sldId id="260" r:id="rId6"/>
+    <p:sldId id="261" r:id="rId7"/>
   </p:sldIdLst>
-  <p:sldSz cx="12191695" cy="6858000" type="screen4x3"/>
+  <p:sldSz cx="12192000" cy="6858000"/>
   <p:notesSz cx="6858000" cy="9144000"/>
   <p:defaultTextStyle>
     <a:defPPr>
@@ -109,6 +109,22 @@
       </a:defRPr>
     </a:lvl9pPr>
   </p:defaultTextStyle>
+  <p:extLst>
+    <p:ext uri="{EFAFB233-063F-42B5-8137-9DF3F51BA10A}">
+      <p15:sldGuideLst xmlns:p15="http://schemas.microsoft.com/office/powerpoint/2012/main">
+        <p15:guide id="1" orient="horz" pos="2160">
+          <p15:clr>
+            <a:srgbClr val="A4A3A4"/>
+          </p15:clr>
+        </p15:guide>
+        <p15:guide id="2" pos="2880">
+          <p15:clr>
+            <a:srgbClr val="A4A3A4"/>
+          </p15:clr>
+        </p15:guide>
+      </p15:sldGuideLst>
+    </p:ext>
+  </p:extLst>
 </p:presentation>
 </file>
 
@@ -150,10 +166,9 @@
           <a:lstStyle/>
           <a:p>
             <a:r>
-              <a:rPr lang="en-US" smtClean="0"/>
+              <a:rPr lang="en-US"/>
               <a:t>Click to edit Master title style</a:t>
             </a:r>
-            <a:endParaRPr lang="en-US"/>
           </a:p>
         </p:txBody>
       </p:sp>
@@ -269,10 +284,9 @@
           </a:lstStyle>
           <a:p>
             <a:r>
-              <a:rPr lang="en-US" smtClean="0"/>
+              <a:rPr lang="en-US"/>
               <a:t>Click to edit Master subtitle style</a:t>
             </a:r>
-            <a:endParaRPr lang="en-US"/>
           </a:p>
         </p:txBody>
       </p:sp>
@@ -293,7 +307,7 @@
           <a:p>
             <a:fld id="{5BCAD085-E8A6-8845-BD4E-CB4CCA059FC4}" type="datetimeFigureOut">
               <a:rPr lang="en-US" smtClean="0"/>
-              <a:t>1/27/13</a:t>
+              <a:t>7/6/2026</a:t>
             </a:fld>
             <a:endParaRPr lang="en-US"/>
           </a:p>
@@ -387,10 +401,9 @@
           <a:lstStyle/>
           <a:p>
             <a:r>
-              <a:rPr lang="en-US" smtClean="0"/>
+              <a:rPr lang="en-US"/>
               <a:t>Click to edit Master title style</a:t>
             </a:r>
-            <a:endParaRPr lang="en-US"/>
           </a:p>
         </p:txBody>
       </p:sp>
@@ -411,38 +424,37 @@
           <a:p>
             <a:pPr lvl="0"/>
             <a:r>
-              <a:rPr lang="en-US" smtClean="0"/>
+              <a:rPr lang="en-US"/>
               <a:t>Click to edit Master text styles</a:t>
             </a:r>
           </a:p>
           <a:p>
             <a:pPr lvl="1"/>
             <a:r>
-              <a:rPr lang="en-US" smtClean="0"/>
+              <a:rPr lang="en-US"/>
               <a:t>Second level</a:t>
             </a:r>
           </a:p>
           <a:p>
             <a:pPr lvl="2"/>
             <a:r>
-              <a:rPr lang="en-US" smtClean="0"/>
+              <a:rPr lang="en-US"/>
               <a:t>Third level</a:t>
             </a:r>
           </a:p>
           <a:p>
             <a:pPr lvl="3"/>
             <a:r>
-              <a:rPr lang="en-US" smtClean="0"/>
+              <a:rPr lang="en-US"/>
               <a:t>Fourth level</a:t>
             </a:r>
           </a:p>
           <a:p>
             <a:pPr lvl="4"/>
             <a:r>
-              <a:rPr lang="en-US" smtClean="0"/>
+              <a:rPr lang="en-US"/>
               <a:t>Fifth level</a:t>
             </a:r>
-            <a:endParaRPr lang="en-US"/>
           </a:p>
         </p:txBody>
       </p:sp>
@@ -463,7 +475,7 @@
           <a:p>
             <a:fld id="{5BCAD085-E8A6-8845-BD4E-CB4CCA059FC4}" type="datetimeFigureOut">
               <a:rPr lang="en-US" smtClean="0"/>
-              <a:t>1/27/13</a:t>
+              <a:t>7/6/2026</a:t>
             </a:fld>
             <a:endParaRPr lang="en-US"/>
           </a:p>
@@ -562,10 +574,9 @@
           <a:lstStyle/>
           <a:p>
             <a:r>
-              <a:rPr lang="en-US" smtClean="0"/>
+              <a:rPr lang="en-US"/>
               <a:t>Click to edit Master title style</a:t>
             </a:r>
-            <a:endParaRPr lang="en-US"/>
           </a:p>
         </p:txBody>
       </p:sp>
@@ -591,38 +602,37 @@
           <a:p>
             <a:pPr lvl="0"/>
             <a:r>
-              <a:rPr lang="en-US" smtClean="0"/>
+              <a:rPr lang="en-US"/>
               <a:t>Click to edit Master text styles</a:t>
             </a:r>
           </a:p>
           <a:p>
             <a:pPr lvl="1"/>
             <a:r>
-              <a:rPr lang="en-US" smtClean="0"/>
+              <a:rPr lang="en-US"/>
               <a:t>Second level</a:t>
             </a:r>
           </a:p>
           <a:p>
             <a:pPr lvl="2"/>
             <a:r>
-              <a:rPr lang="en-US" smtClean="0"/>
+              <a:rPr lang="en-US"/>
               <a:t>Third level</a:t>
             </a:r>
           </a:p>
           <a:p>
             <a:pPr lvl="3"/>
             <a:r>
-              <a:rPr lang="en-US" smtClean="0"/>
+              <a:rPr lang="en-US"/>
               <a:t>Fourth level</a:t>
             </a:r>
           </a:p>
           <a:p>
             <a:pPr lvl="4"/>
             <a:r>
-              <a:rPr lang="en-US" smtClean="0"/>
+              <a:rPr lang="en-US"/>
               <a:t>Fifth level</a:t>
             </a:r>
-            <a:endParaRPr lang="en-US"/>
           </a:p>
         </p:txBody>
       </p:sp>
@@ -643,7 +653,7 @@
           <a:p>
             <a:fld id="{5BCAD085-E8A6-8845-BD4E-CB4CCA059FC4}" type="datetimeFigureOut">
               <a:rPr lang="en-US" smtClean="0"/>
-              <a:t>1/27/13</a:t>
+              <a:t>7/6/2026</a:t>
             </a:fld>
             <a:endParaRPr lang="en-US"/>
           </a:p>
@@ -737,10 +747,9 @@
           <a:lstStyle/>
           <a:p>
             <a:r>
-              <a:rPr lang="en-US" smtClean="0"/>
+              <a:rPr lang="en-US"/>
               <a:t>Click to edit Master title style</a:t>
             </a:r>
-            <a:endParaRPr lang="en-US"/>
           </a:p>
         </p:txBody>
       </p:sp>
@@ -761,38 +770,37 @@
           <a:p>
             <a:pPr lvl="0"/>
             <a:r>
-              <a:rPr lang="en-US" smtClean="0"/>
+              <a:rPr lang="en-US"/>
               <a:t>Click to edit Master text styles</a:t>
             </a:r>
           </a:p>
           <a:p>
             <a:pPr lvl="1"/>
             <a:r>
-              <a:rPr lang="en-US" smtClean="0"/>
+              <a:rPr lang="en-US"/>
               <a:t>Second level</a:t>
             </a:r>
           </a:p>
           <a:p>
             <a:pPr lvl="2"/>
             <a:r>
-              <a:rPr lang="en-US" smtClean="0"/>
+              <a:rPr lang="en-US"/>
               <a:t>Third level</a:t>
             </a:r>
           </a:p>
           <a:p>
             <a:pPr lvl="3"/>
             <a:r>
-              <a:rPr lang="en-US" smtClean="0"/>
+              <a:rPr lang="en-US"/>
               <a:t>Fourth level</a:t>
             </a:r>
           </a:p>
           <a:p>
             <a:pPr lvl="4"/>
             <a:r>
-              <a:rPr lang="en-US" smtClean="0"/>
+              <a:rPr lang="en-US"/>
               <a:t>Fifth level</a:t>
             </a:r>
-            <a:endParaRPr lang="en-US"/>
           </a:p>
         </p:txBody>
       </p:sp>
@@ -813,7 +821,7 @@
           <a:p>
             <a:fld id="{5BCAD085-E8A6-8845-BD4E-CB4CCA059FC4}" type="datetimeFigureOut">
               <a:rPr lang="en-US" smtClean="0"/>
-              <a:t>1/27/13</a:t>
+              <a:t>7/6/2026</a:t>
             </a:fld>
             <a:endParaRPr lang="en-US"/>
           </a:p>
@@ -916,10 +924,9 @@
           </a:lstStyle>
           <a:p>
             <a:r>
-              <a:rPr lang="en-US" smtClean="0"/>
+              <a:rPr lang="en-US"/>
               <a:t>Click to edit Master title style</a:t>
             </a:r>
-            <a:endParaRPr lang="en-US"/>
           </a:p>
         </p:txBody>
       </p:sp>
@@ -1036,7 +1043,7 @@
           <a:p>
             <a:pPr lvl="0"/>
             <a:r>
-              <a:rPr lang="en-US" smtClean="0"/>
+              <a:rPr lang="en-US"/>
               <a:t>Click to edit Master text styles</a:t>
             </a:r>
           </a:p>
@@ -1059,7 +1066,7 @@
           <a:p>
             <a:fld id="{5BCAD085-E8A6-8845-BD4E-CB4CCA059FC4}" type="datetimeFigureOut">
               <a:rPr lang="en-US" smtClean="0"/>
-              <a:t>1/27/13</a:t>
+              <a:t>7/6/2026</a:t>
             </a:fld>
             <a:endParaRPr lang="en-US"/>
           </a:p>
@@ -1153,10 +1160,9 @@
           <a:lstStyle/>
           <a:p>
             <a:r>
-              <a:rPr lang="en-US" smtClean="0"/>
+              <a:rPr lang="en-US"/>
               <a:t>Click to edit Master title style</a:t>
             </a:r>
-            <a:endParaRPr lang="en-US"/>
           </a:p>
         </p:txBody>
       </p:sp>
@@ -1210,38 +1216,37 @@
           <a:p>
             <a:pPr lvl="0"/>
             <a:r>
-              <a:rPr lang="en-US" smtClean="0"/>
+              <a:rPr lang="en-US"/>
               <a:t>Click to edit Master text styles</a:t>
             </a:r>
           </a:p>
           <a:p>
             <a:pPr lvl="1"/>
             <a:r>
-              <a:rPr lang="en-US" smtClean="0"/>
+              <a:rPr lang="en-US"/>
               <a:t>Second level</a:t>
             </a:r>
           </a:p>
           <a:p>
             <a:pPr lvl="2"/>
             <a:r>
-              <a:rPr lang="en-US" smtClean="0"/>
+              <a:rPr lang="en-US"/>
               <a:t>Third level</a:t>
             </a:r>
           </a:p>
           <a:p>
             <a:pPr lvl="3"/>
             <a:r>
-              <a:rPr lang="en-US" smtClean="0"/>
+              <a:rPr lang="en-US"/>
               <a:t>Fourth level</a:t>
             </a:r>
           </a:p>
           <a:p>
             <a:pPr lvl="4"/>
             <a:r>
-              <a:rPr lang="en-US" smtClean="0"/>
+              <a:rPr lang="en-US"/>
               <a:t>Fifth level</a:t>
             </a:r>
-            <a:endParaRPr lang="en-US"/>
           </a:p>
         </p:txBody>
       </p:sp>
@@ -1295,38 +1300,37 @@
           <a:p>
             <a:pPr lvl="0"/>
             <a:r>
-              <a:rPr lang="en-US" smtClean="0"/>
+              <a:rPr lang="en-US"/>
               <a:t>Click to edit Master text styles</a:t>
             </a:r>
           </a:p>
           <a:p>
             <a:pPr lvl="1"/>
             <a:r>
-              <a:rPr lang="en-US" smtClean="0"/>
+              <a:rPr lang="en-US"/>
               <a:t>Second level</a:t>
             </a:r>
           </a:p>
           <a:p>
             <a:pPr lvl="2"/>
             <a:r>
-              <a:rPr lang="en-US" smtClean="0"/>
+              <a:rPr lang="en-US"/>
               <a:t>Third level</a:t>
             </a:r>
           </a:p>
           <a:p>
             <a:pPr lvl="3"/>
             <a:r>
-              <a:rPr lang="en-US" smtClean="0"/>
+              <a:rPr lang="en-US"/>
               <a:t>Fourth level</a:t>
             </a:r>
           </a:p>
           <a:p>
             <a:pPr lvl="4"/>
             <a:r>
-              <a:rPr lang="en-US" smtClean="0"/>
+              <a:rPr lang="en-US"/>
               <a:t>Fifth level</a:t>
             </a:r>
-            <a:endParaRPr lang="en-US"/>
           </a:p>
         </p:txBody>
       </p:sp>
@@ -1347,7 +1351,7 @@
           <a:p>
             <a:fld id="{5BCAD085-E8A6-8845-BD4E-CB4CCA059FC4}" type="datetimeFigureOut">
               <a:rPr lang="en-US" smtClean="0"/>
-              <a:t>1/27/13</a:t>
+              <a:t>7/6/2026</a:t>
             </a:fld>
             <a:endParaRPr lang="en-US"/>
           </a:p>
@@ -1445,10 +1449,9 @@
           </a:lstStyle>
           <a:p>
             <a:r>
-              <a:rPr lang="en-US" smtClean="0"/>
+              <a:rPr lang="en-US"/>
               <a:t>Click to edit Master title style</a:t>
             </a:r>
-            <a:endParaRPr lang="en-US"/>
           </a:p>
         </p:txBody>
       </p:sp>
@@ -1511,7 +1514,7 @@
           <a:p>
             <a:pPr lvl="0"/>
             <a:r>
-              <a:rPr lang="en-US" smtClean="0"/>
+              <a:rPr lang="en-US"/>
               <a:t>Click to edit Master text styles</a:t>
             </a:r>
           </a:p>
@@ -1567,38 +1570,37 @@
           <a:p>
             <a:pPr lvl="0"/>
             <a:r>
-              <a:rPr lang="en-US" smtClean="0"/>
+              <a:rPr lang="en-US"/>
               <a:t>Click to edit Master text styles</a:t>
             </a:r>
           </a:p>
           <a:p>
             <a:pPr lvl="1"/>
             <a:r>
-              <a:rPr lang="en-US" smtClean="0"/>
+              <a:rPr lang="en-US"/>
               <a:t>Second level</a:t>
             </a:r>
           </a:p>
           <a:p>
             <a:pPr lvl="2"/>
             <a:r>
-              <a:rPr lang="en-US" smtClean="0"/>
+              <a:rPr lang="en-US"/>
               <a:t>Third level</a:t>
             </a:r>
           </a:p>
           <a:p>
             <a:pPr lvl="3"/>
             <a:r>
-              <a:rPr lang="en-US" smtClean="0"/>
+              <a:rPr lang="en-US"/>
               <a:t>Fourth level</a:t>
             </a:r>
           </a:p>
           <a:p>
             <a:pPr lvl="4"/>
             <a:r>
-              <a:rPr lang="en-US" smtClean="0"/>
+              <a:rPr lang="en-US"/>
               <a:t>Fifth level</a:t>
             </a:r>
-            <a:endParaRPr lang="en-US"/>
           </a:p>
         </p:txBody>
       </p:sp>
@@ -1661,7 +1663,7 @@
           <a:p>
             <a:pPr lvl="0"/>
             <a:r>
-              <a:rPr lang="en-US" smtClean="0"/>
+              <a:rPr lang="en-US"/>
               <a:t>Click to edit Master text styles</a:t>
             </a:r>
           </a:p>
@@ -1717,38 +1719,37 @@
           <a:p>
             <a:pPr lvl="0"/>
             <a:r>
-              <a:rPr lang="en-US" smtClean="0"/>
+              <a:rPr lang="en-US"/>
               <a:t>Click to edit Master text styles</a:t>
             </a:r>
           </a:p>
           <a:p>
             <a:pPr lvl="1"/>
             <a:r>
-              <a:rPr lang="en-US" smtClean="0"/>
+              <a:rPr lang="en-US"/>
               <a:t>Second level</a:t>
             </a:r>
           </a:p>
           <a:p>
             <a:pPr lvl="2"/>
             <a:r>
-              <a:rPr lang="en-US" smtClean="0"/>
+              <a:rPr lang="en-US"/>
               <a:t>Third level</a:t>
             </a:r>
           </a:p>
           <a:p>
             <a:pPr lvl="3"/>
             <a:r>
-              <a:rPr lang="en-US" smtClean="0"/>
+              <a:rPr lang="en-US"/>
               <a:t>Fourth level</a:t>
             </a:r>
           </a:p>
           <a:p>
             <a:pPr lvl="4"/>
             <a:r>
-              <a:rPr lang="en-US" smtClean="0"/>
+              <a:rPr lang="en-US"/>
               <a:t>Fifth level</a:t>
             </a:r>
-            <a:endParaRPr lang="en-US"/>
           </a:p>
         </p:txBody>
       </p:sp>
@@ -1769,7 +1770,7 @@
           <a:p>
             <a:fld id="{5BCAD085-E8A6-8845-BD4E-CB4CCA059FC4}" type="datetimeFigureOut">
               <a:rPr lang="en-US" smtClean="0"/>
-              <a:t>1/27/13</a:t>
+              <a:t>7/6/2026</a:t>
             </a:fld>
             <a:endParaRPr lang="en-US"/>
           </a:p>
@@ -1863,10 +1864,9 @@
           <a:lstStyle/>
           <a:p>
             <a:r>
-              <a:rPr lang="en-US" smtClean="0"/>
+              <a:rPr lang="en-US"/>
               <a:t>Click to edit Master title style</a:t>
             </a:r>
-            <a:endParaRPr lang="en-US"/>
           </a:p>
         </p:txBody>
       </p:sp>
@@ -1887,7 +1887,7 @@
           <a:p>
             <a:fld id="{5BCAD085-E8A6-8845-BD4E-CB4CCA059FC4}" type="datetimeFigureOut">
               <a:rPr lang="en-US" smtClean="0"/>
-              <a:t>1/27/13</a:t>
+              <a:t>7/6/2026</a:t>
             </a:fld>
             <a:endParaRPr lang="en-US"/>
           </a:p>
@@ -1982,7 +1982,7 @@
           <a:p>
             <a:fld id="{5BCAD085-E8A6-8845-BD4E-CB4CCA059FC4}" type="datetimeFigureOut">
               <a:rPr lang="en-US" smtClean="0"/>
-              <a:t>1/27/13</a:t>
+              <a:t>7/6/2026</a:t>
             </a:fld>
             <a:endParaRPr lang="en-US"/>
           </a:p>
@@ -2085,10 +2085,9 @@
           </a:lstStyle>
           <a:p>
             <a:r>
-              <a:rPr lang="en-US" smtClean="0"/>
+              <a:rPr lang="en-US"/>
               <a:t>Click to edit Master title style</a:t>
             </a:r>
-            <a:endParaRPr lang="en-US"/>
           </a:p>
         </p:txBody>
       </p:sp>
@@ -2142,38 +2141,37 @@
           <a:p>
             <a:pPr lvl="0"/>
             <a:r>
-              <a:rPr lang="en-US" smtClean="0"/>
+              <a:rPr lang="en-US"/>
               <a:t>Click to edit Master text styles</a:t>
             </a:r>
           </a:p>
           <a:p>
             <a:pPr lvl="1"/>
             <a:r>
-              <a:rPr lang="en-US" smtClean="0"/>
+              <a:rPr lang="en-US"/>
               <a:t>Second level</a:t>
             </a:r>
           </a:p>
           <a:p>
             <a:pPr lvl="2"/>
             <a:r>
-              <a:rPr lang="en-US" smtClean="0"/>
+              <a:rPr lang="en-US"/>
               <a:t>Third level</a:t>
             </a:r>
           </a:p>
           <a:p>
             <a:pPr lvl="3"/>
             <a:r>
-              <a:rPr lang="en-US" smtClean="0"/>
+              <a:rPr lang="en-US"/>
               <a:t>Fourth level</a:t>
             </a:r>
           </a:p>
           <a:p>
             <a:pPr lvl="4"/>
             <a:r>
-              <a:rPr lang="en-US" smtClean="0"/>
+              <a:rPr lang="en-US"/>
               <a:t>Fifth level</a:t>
             </a:r>
-            <a:endParaRPr lang="en-US"/>
           </a:p>
         </p:txBody>
       </p:sp>
@@ -2236,7 +2234,7 @@
           <a:p>
             <a:pPr lvl="0"/>
             <a:r>
-              <a:rPr lang="en-US" smtClean="0"/>
+              <a:rPr lang="en-US"/>
               <a:t>Click to edit Master text styles</a:t>
             </a:r>
           </a:p>
@@ -2259,7 +2257,7 @@
           <a:p>
             <a:fld id="{5BCAD085-E8A6-8845-BD4E-CB4CCA059FC4}" type="datetimeFigureOut">
               <a:rPr lang="en-US" smtClean="0"/>
-              <a:t>1/27/13</a:t>
+              <a:t>7/6/2026</a:t>
             </a:fld>
             <a:endParaRPr lang="en-US"/>
           </a:p>
@@ -2362,10 +2360,9 @@
           </a:lstStyle>
           <a:p>
             <a:r>
-              <a:rPr lang="en-US" smtClean="0"/>
+              <a:rPr lang="en-US"/>
               <a:t>Click to edit Master title style</a:t>
             </a:r>
-            <a:endParaRPr lang="en-US"/>
           </a:p>
         </p:txBody>
       </p:sp>
@@ -2489,7 +2486,7 @@
           <a:p>
             <a:pPr lvl="0"/>
             <a:r>
-              <a:rPr lang="en-US" smtClean="0"/>
+              <a:rPr lang="en-US"/>
               <a:t>Click to edit Master text styles</a:t>
             </a:r>
           </a:p>
@@ -2512,7 +2509,7 @@
           <a:p>
             <a:fld id="{5BCAD085-E8A6-8845-BD4E-CB4CCA059FC4}" type="datetimeFigureOut">
               <a:rPr lang="en-US" smtClean="0"/>
-              <a:t>1/27/13</a:t>
+              <a:t>7/6/2026</a:t>
             </a:fld>
             <a:endParaRPr lang="en-US"/>
           </a:p>
@@ -2621,10 +2618,9 @@
           <a:lstStyle/>
           <a:p>
             <a:r>
-              <a:rPr lang="en-US" smtClean="0"/>
+              <a:rPr lang="en-US"/>
               <a:t>Click to edit Master title style</a:t>
             </a:r>
-            <a:endParaRPr lang="en-US"/>
           </a:p>
         </p:txBody>
       </p:sp>
@@ -2655,38 +2651,37 @@
           <a:p>
             <a:pPr lvl="0"/>
             <a:r>
-              <a:rPr lang="en-US" smtClean="0"/>
+              <a:rPr lang="en-US"/>
               <a:t>Click to edit Master text styles</a:t>
             </a:r>
           </a:p>
           <a:p>
             <a:pPr lvl="1"/>
             <a:r>
-              <a:rPr lang="en-US" smtClean="0"/>
+              <a:rPr lang="en-US"/>
               <a:t>Second level</a:t>
             </a:r>
           </a:p>
           <a:p>
             <a:pPr lvl="2"/>
             <a:r>
-              <a:rPr lang="en-US" smtClean="0"/>
+              <a:rPr lang="en-US"/>
               <a:t>Third level</a:t>
             </a:r>
           </a:p>
           <a:p>
             <a:pPr lvl="3"/>
             <a:r>
-              <a:rPr lang="en-US" smtClean="0"/>
+              <a:rPr lang="en-US"/>
               <a:t>Fourth level</a:t>
             </a:r>
           </a:p>
           <a:p>
             <a:pPr lvl="4"/>
             <a:r>
-              <a:rPr lang="en-US" smtClean="0"/>
+              <a:rPr lang="en-US"/>
               <a:t>Fifth level</a:t>
             </a:r>
-            <a:endParaRPr lang="en-US"/>
           </a:p>
         </p:txBody>
       </p:sp>
@@ -2725,7 +2720,7 @@
           <a:p>
             <a:fld id="{5BCAD085-E8A6-8845-BD4E-CB4CCA059FC4}" type="datetimeFigureOut">
               <a:rPr lang="en-US" smtClean="0"/>
-              <a:t>1/27/13</a:t>
+              <a:t>7/6/2026</a:t>
             </a:fld>
             <a:endParaRPr lang="en-US"/>
           </a:p>
@@ -3084,7 +3079,7 @@
 </file>
 
 <file path=ppt/slides/slide1.xml><?xml version="1.0" encoding="utf-8"?>
-<p:sld xmlns:a="http://schemas.openxmlformats.org/drawingml/2006/main" xmlns:p="http://schemas.openxmlformats.org/presentationml/2006/main" xmlns:r="http://schemas.openxmlformats.org/officeDocument/2006/relationships">
+<p:sld xmlns:a="http://schemas.openxmlformats.org/drawingml/2006/main" xmlns:r="http://schemas.openxmlformats.org/officeDocument/2006/relationships" xmlns:p="http://schemas.openxmlformats.org/presentationml/2006/main">
   <p:cSld>
     <p:bg>
       <p:bgPr>
@@ -3100,7 +3095,14 @@
         <p:cNvGrpSpPr/>
         <p:nvPr/>
       </p:nvGrpSpPr>
-      <p:grpSpPr/>
+      <p:grpSpPr>
+        <a:xfrm>
+          <a:off x="0" y="0"/>
+          <a:ext cx="0" cy="0"/>
+          <a:chOff x="0" y="0"/>
+          <a:chExt cx="0" cy="0"/>
+        </a:xfrm>
+      </p:grpSpPr>
       <p:sp>
         <p:nvSpPr>
           <p:cNvPr id="2" name="Rectangle 1"/>
@@ -3141,6 +3143,7 @@
           <a:lstStyle/>
           <a:p>
             <a:pPr algn="ctr"/>
+            <a:endParaRPr/>
           </a:p>
         </p:txBody>
       </p:sp>
@@ -3184,6 +3187,7 @@
           <a:lstStyle/>
           <a:p>
             <a:pPr algn="ctr"/>
+            <a:endParaRPr/>
           </a:p>
         </p:txBody>
       </p:sp>
@@ -3332,6 +3336,7 @@
           <a:lstStyle/>
           <a:p>
             <a:pPr algn="ctr"/>
+            <a:endParaRPr/>
           </a:p>
         </p:txBody>
       </p:sp>
@@ -3397,7 +3402,7 @@
 </file>
 
 <file path=ppt/slides/slide2.xml><?xml version="1.0" encoding="utf-8"?>
-<p:sld xmlns:a="http://schemas.openxmlformats.org/drawingml/2006/main" xmlns:p="http://schemas.openxmlformats.org/presentationml/2006/main" xmlns:r="http://schemas.openxmlformats.org/officeDocument/2006/relationships">
+<p:sld xmlns:a="http://schemas.openxmlformats.org/drawingml/2006/main" xmlns:r="http://schemas.openxmlformats.org/officeDocument/2006/relationships" xmlns:p="http://schemas.openxmlformats.org/presentationml/2006/main">
   <p:cSld>
     <p:bg>
       <p:bgPr>
@@ -3413,7 +3418,14 @@
         <p:cNvGrpSpPr/>
         <p:nvPr/>
       </p:nvGrpSpPr>
-      <p:grpSpPr/>
+      <p:grpSpPr>
+        <a:xfrm>
+          <a:off x="0" y="0"/>
+          <a:ext cx="0" cy="0"/>
+          <a:chOff x="0" y="0"/>
+          <a:chExt cx="0" cy="0"/>
+        </a:xfrm>
+      </p:grpSpPr>
       <p:sp>
         <p:nvSpPr>
           <p:cNvPr id="2" name="Rectangle 1"/>
@@ -3454,6 +3466,7 @@
           <a:lstStyle/>
           <a:p>
             <a:pPr algn="ctr"/>
+            <a:endParaRPr/>
           </a:p>
         </p:txBody>
       </p:sp>
@@ -3500,7 +3513,7 @@
         </p:nvSpPr>
         <p:spPr>
           <a:xfrm>
-            <a:off x="1371600" y="2743200"/>
+            <a:off x="663389" y="2549563"/>
             <a:ext cx="9144000" cy="731520"/>
           </a:xfrm>
           <a:prstGeom prst="rect">
@@ -3522,7 +3535,40 @@
               </a:defRPr>
             </a:pPr>
             <a:r>
-              <a:t>90% кандидатов проваливаются в клинике из-за ADME/Tox</a:t>
+              <a:rPr dirty="0"/>
+              <a:t>90% </a:t>
+            </a:r>
+            <a:r>
+              <a:rPr dirty="0" err="1"/>
+              <a:t>кандидатов</a:t>
+            </a:r>
+            <a:r>
+              <a:rPr dirty="0"/>
+              <a:t> </a:t>
+            </a:r>
+            <a:r>
+              <a:rPr dirty="0" err="1"/>
+              <a:t>проваливаются</a:t>
+            </a:r>
+            <a:r>
+              <a:rPr dirty="0"/>
+              <a:t> в </a:t>
+            </a:r>
+            <a:r>
+              <a:rPr dirty="0" err="1"/>
+              <a:t>клинике</a:t>
+            </a:r>
+            <a:r>
+              <a:rPr dirty="0"/>
+              <a:t> </a:t>
+            </a:r>
+            <a:r>
+              <a:rPr dirty="0" err="1"/>
+              <a:t>из-за</a:t>
+            </a:r>
+            <a:r>
+              <a:rPr dirty="0"/>
+              <a:t> ADME/Tox</a:t>
             </a:r>
           </a:p>
         </p:txBody>
@@ -3535,7 +3581,7 @@
         </p:nvSpPr>
         <p:spPr>
           <a:xfrm>
-            <a:off x="548640" y="1371600"/>
+            <a:off x="914400" y="3281083"/>
             <a:ext cx="5029200" cy="4572000"/>
           </a:xfrm>
           <a:prstGeom prst="rect">
@@ -3560,8 +3606,38 @@
               </a:defRPr>
             </a:pPr>
             <a:r>
-              <a:t>  Стоимость разработки препарата: $2.23 млрд</a:t>
-            </a:r>
+              <a:rPr dirty="0"/>
+              <a:t>  </a:t>
+            </a:r>
+            <a:r>
+              <a:rPr dirty="0" err="1"/>
+              <a:t>Стоимость</a:t>
+            </a:r>
+            <a:r>
+              <a:rPr dirty="0"/>
+              <a:t> </a:t>
+            </a:r>
+            <a:r>
+              <a:rPr dirty="0" err="1"/>
+              <a:t>разработки</a:t>
+            </a:r>
+            <a:r>
+              <a:rPr dirty="0"/>
+              <a:t> </a:t>
+            </a:r>
+            <a:r>
+              <a:rPr dirty="0" err="1"/>
+              <a:t>препарата</a:t>
+            </a:r>
+            <a:r>
+              <a:rPr dirty="0"/>
+              <a:t>: $2.23 </a:t>
+            </a:r>
+            <a:r>
+              <a:rPr dirty="0" err="1"/>
+              <a:t>млрд</a:t>
+            </a:r>
+            <a:endParaRPr dirty="0"/>
           </a:p>
           <a:p>
             <a:pPr>
@@ -3575,7 +3651,32 @@
               </a:defRPr>
             </a:pPr>
             <a:r>
-              <a:t>  60% бюджета уходит на lead optimization</a:t>
+              <a:rPr dirty="0"/>
+              <a:t>  60% </a:t>
+            </a:r>
+            <a:r>
+              <a:rPr dirty="0" err="1"/>
+              <a:t>бюджета</a:t>
+            </a:r>
+            <a:r>
+              <a:rPr dirty="0"/>
+              <a:t> </a:t>
+            </a:r>
+            <a:r>
+              <a:rPr dirty="0" err="1"/>
+              <a:t>уходит</a:t>
+            </a:r>
+            <a:r>
+              <a:rPr dirty="0"/>
+              <a:t> </a:t>
+            </a:r>
+            <a:r>
+              <a:rPr dirty="0" err="1"/>
+              <a:t>на</a:t>
+            </a:r>
+            <a:r>
+              <a:rPr dirty="0"/>
+              <a:t> lead optimization</a:t>
             </a:r>
           </a:p>
           <a:p>
@@ -3590,8 +3691,54 @@
               </a:defRPr>
             </a:pPr>
             <a:r>
-              <a:t>  Eroom's Law: эффективность R&amp;D падает вдвое каждые 9 лет</a:t>
-            </a:r>
+              <a:rPr dirty="0"/>
+              <a:t>  </a:t>
+            </a:r>
+            <a:r>
+              <a:rPr dirty="0" err="1"/>
+              <a:t>Eroom's</a:t>
+            </a:r>
+            <a:r>
+              <a:rPr dirty="0"/>
+              <a:t> Law: </a:t>
+            </a:r>
+            <a:r>
+              <a:rPr dirty="0" err="1"/>
+              <a:t>эффективность</a:t>
+            </a:r>
+            <a:r>
+              <a:rPr dirty="0"/>
+              <a:t> R&amp;D </a:t>
+            </a:r>
+            <a:r>
+              <a:rPr dirty="0" err="1"/>
+              <a:t>падает</a:t>
+            </a:r>
+            <a:r>
+              <a:rPr dirty="0"/>
+              <a:t> </a:t>
+            </a:r>
+            <a:r>
+              <a:rPr dirty="0" err="1"/>
+              <a:t>вдвое</a:t>
+            </a:r>
+            <a:r>
+              <a:rPr dirty="0"/>
+              <a:t> </a:t>
+            </a:r>
+            <a:r>
+              <a:rPr dirty="0" err="1"/>
+              <a:t>каждые</a:t>
+            </a:r>
+            <a:r>
+              <a:rPr dirty="0"/>
+              <a:t> 9 </a:t>
+            </a:r>
+            <a:r>
+              <a:rPr dirty="0" err="1"/>
+              <a:t>лет</a:t>
+            </a:r>
+            <a:endParaRPr dirty="0"/>
           </a:p>
           <a:p>
             <a:pPr>
@@ -3605,8 +3752,46 @@
               </a:defRPr>
             </a:pPr>
             <a:r>
-              <a:t>  Скрининг требует синтеза тысяч молекул</a:t>
-            </a:r>
+              <a:rPr dirty="0"/>
+              <a:t>  </a:t>
+            </a:r>
+            <a:r>
+              <a:rPr dirty="0" err="1"/>
+              <a:t>Скрининг</a:t>
+            </a:r>
+            <a:r>
+              <a:rPr dirty="0"/>
+              <a:t> </a:t>
+            </a:r>
+            <a:r>
+              <a:rPr dirty="0" err="1"/>
+              <a:t>требует</a:t>
+            </a:r>
+            <a:r>
+              <a:rPr dirty="0"/>
+              <a:t> </a:t>
+            </a:r>
+            <a:r>
+              <a:rPr dirty="0" err="1"/>
+              <a:t>синтеза</a:t>
+            </a:r>
+            <a:r>
+              <a:rPr dirty="0"/>
+              <a:t> </a:t>
+            </a:r>
+            <a:r>
+              <a:rPr dirty="0" err="1"/>
+              <a:t>тысяч</a:t>
+            </a:r>
+            <a:r>
+              <a:rPr dirty="0"/>
+              <a:t> </a:t>
+            </a:r>
+            <a:r>
+              <a:rPr dirty="0" err="1"/>
+              <a:t>молекул</a:t>
+            </a:r>
+            <a:endParaRPr dirty="0"/>
           </a:p>
         </p:txBody>
       </p:sp>
@@ -3674,6 +3859,7 @@
           <a:lstStyle/>
           <a:p>
             <a:pPr algn="ctr"/>
+            <a:endParaRPr/>
           </a:p>
         </p:txBody>
       </p:sp>
@@ -3721,7 +3907,7 @@
 </file>
 
 <file path=ppt/slides/slide3.xml><?xml version="1.0" encoding="utf-8"?>
-<p:sld xmlns:a="http://schemas.openxmlformats.org/drawingml/2006/main" xmlns:p="http://schemas.openxmlformats.org/presentationml/2006/main" xmlns:r="http://schemas.openxmlformats.org/officeDocument/2006/relationships">
+<p:sld xmlns:a="http://schemas.openxmlformats.org/drawingml/2006/main" xmlns:r="http://schemas.openxmlformats.org/officeDocument/2006/relationships" xmlns:p="http://schemas.openxmlformats.org/presentationml/2006/main">
   <p:cSld>
     <p:bg>
       <p:bgPr>
@@ -3737,7 +3923,14 @@
         <p:cNvGrpSpPr/>
         <p:nvPr/>
       </p:nvGrpSpPr>
-      <p:grpSpPr/>
+      <p:grpSpPr>
+        <a:xfrm>
+          <a:off x="0" y="0"/>
+          <a:ext cx="0" cy="0"/>
+          <a:chOff x="0" y="0"/>
+          <a:chExt cx="0" cy="0"/>
+        </a:xfrm>
+      </p:grpSpPr>
       <p:sp>
         <p:nvSpPr>
           <p:cNvPr id="2" name="Rectangle 1"/>
@@ -3778,6 +3971,7 @@
           <a:lstStyle/>
           <a:p>
             <a:pPr algn="ctr"/>
+            <a:endParaRPr/>
           </a:p>
         </p:txBody>
       </p:sp>
@@ -3915,6 +4109,7 @@
           <a:lstStyle/>
           <a:p>
             <a:pPr algn="ctr"/>
+            <a:endParaRPr/>
           </a:p>
         </p:txBody>
       </p:sp>
@@ -4907,7 +5102,7 @@
 </file>
 
 <file path=ppt/slides/slide4.xml><?xml version="1.0" encoding="utf-8"?>
-<p:sld xmlns:a="http://schemas.openxmlformats.org/drawingml/2006/main" xmlns:p="http://schemas.openxmlformats.org/presentationml/2006/main" xmlns:r="http://schemas.openxmlformats.org/officeDocument/2006/relationships">
+<p:sld xmlns:a="http://schemas.openxmlformats.org/drawingml/2006/main" xmlns:r="http://schemas.openxmlformats.org/officeDocument/2006/relationships" xmlns:p="http://schemas.openxmlformats.org/presentationml/2006/main">
   <p:cSld>
     <p:bg>
       <p:bgPr>
@@ -4923,7 +5118,14 @@
         <p:cNvGrpSpPr/>
         <p:nvPr/>
       </p:nvGrpSpPr>
-      <p:grpSpPr/>
+      <p:grpSpPr>
+        <a:xfrm>
+          <a:off x="0" y="0"/>
+          <a:ext cx="0" cy="0"/>
+          <a:chOff x="0" y="0"/>
+          <a:chExt cx="0" cy="0"/>
+        </a:xfrm>
+      </p:grpSpPr>
       <p:sp>
         <p:nvSpPr>
           <p:cNvPr id="2" name="Rectangle 1"/>
@@ -4964,6 +5166,7 @@
           <a:lstStyle/>
           <a:p>
             <a:pPr algn="ctr"/>
+            <a:endParaRPr/>
           </a:p>
         </p:txBody>
       </p:sp>
@@ -5168,7 +5371,7 @@
 </file>
 
 <file path=ppt/slides/slide5.xml><?xml version="1.0" encoding="utf-8"?>
-<p:sld xmlns:a="http://schemas.openxmlformats.org/drawingml/2006/main" xmlns:p="http://schemas.openxmlformats.org/presentationml/2006/main" xmlns:r="http://schemas.openxmlformats.org/officeDocument/2006/relationships">
+<p:sld xmlns:a="http://schemas.openxmlformats.org/drawingml/2006/main" xmlns:r="http://schemas.openxmlformats.org/officeDocument/2006/relationships" xmlns:p="http://schemas.openxmlformats.org/presentationml/2006/main">
   <p:cSld>
     <p:bg>
       <p:bgPr>
@@ -5184,7 +5387,14 @@
         <p:cNvGrpSpPr/>
         <p:nvPr/>
       </p:nvGrpSpPr>
-      <p:grpSpPr/>
+      <p:grpSpPr>
+        <a:xfrm>
+          <a:off x="0" y="0"/>
+          <a:ext cx="0" cy="0"/>
+          <a:chOff x="0" y="0"/>
+          <a:chExt cx="0" cy="0"/>
+        </a:xfrm>
+      </p:grpSpPr>
       <p:sp>
         <p:nvSpPr>
           <p:cNvPr id="2" name="Rectangle 1"/>
@@ -5225,6 +5435,7 @@
           <a:lstStyle/>
           <a:p>
             <a:pPr algn="ctr"/>
+            <a:endParaRPr/>
           </a:p>
         </p:txBody>
       </p:sp>
@@ -5236,7 +5447,7 @@
         </p:nvSpPr>
         <p:spPr>
           <a:xfrm>
-            <a:off x="1371600" y="1371600"/>
+            <a:off x="914400" y="960120"/>
             <a:ext cx="9144000" cy="914400"/>
           </a:xfrm>
           <a:prstGeom prst="rect">
@@ -5258,8 +5469,18 @@
               </a:defRPr>
             </a:pPr>
             <a:r>
-              <a:t>Дорожная карта</a:t>
-            </a:r>
+              <a:rPr dirty="0" err="1"/>
+              <a:t>Дорожная</a:t>
+            </a:r>
+            <a:r>
+              <a:rPr dirty="0"/>
+              <a:t> </a:t>
+            </a:r>
+            <a:r>
+              <a:rPr dirty="0" err="1"/>
+              <a:t>карта</a:t>
+            </a:r>
+            <a:endParaRPr dirty="0"/>
           </a:p>
         </p:txBody>
       </p:sp>
@@ -5338,6 +5559,7 @@
           <a:lstStyle/>
           <a:p>
             <a:pPr algn="ctr"/>
+            <a:endParaRPr/>
           </a:p>
         </p:txBody>
       </p:sp>
@@ -5419,7 +5641,7 @@
         </p:nvSpPr>
         <p:spPr>
           <a:xfrm>
-            <a:off x="1005840" y="2926080"/>
+            <a:off x="868680" y="3212951"/>
             <a:ext cx="3108960" cy="3200400"/>
           </a:xfrm>
           <a:prstGeom prst="rect">
@@ -5444,8 +5666,22 @@
               </a:defRPr>
             </a:pPr>
             <a:r>
-              <a:t>    3 модели LightGBM</a:t>
-            </a:r>
+              <a:rPr dirty="0"/>
+              <a:t>    3 </a:t>
+            </a:r>
+            <a:r>
+              <a:rPr dirty="0" err="1"/>
+              <a:t>модели</a:t>
+            </a:r>
+            <a:r>
+              <a:rPr dirty="0"/>
+              <a:t> </a:t>
+            </a:r>
+            <a:r>
+              <a:rPr dirty="0" err="1"/>
+              <a:t>LightGBM</a:t>
+            </a:r>
+            <a:endParaRPr dirty="0"/>
           </a:p>
           <a:p>
             <a:pPr>
@@ -5459,8 +5695,22 @@
               </a:defRPr>
             </a:pPr>
             <a:r>
-              <a:t>    Streamlit веб-интерфейс</a:t>
-            </a:r>
+              <a:rPr dirty="0"/>
+              <a:t>    </a:t>
+            </a:r>
+            <a:r>
+              <a:rPr dirty="0" err="1"/>
+              <a:t>Streamlit</a:t>
+            </a:r>
+            <a:r>
+              <a:rPr dirty="0"/>
+              <a:t> </a:t>
+            </a:r>
+            <a:r>
+              <a:rPr dirty="0" err="1"/>
+              <a:t>веб-интерфейс</a:t>
+            </a:r>
+            <a:endParaRPr dirty="0"/>
           </a:p>
           <a:p>
             <a:pPr>
@@ -5474,8 +5724,30 @@
               </a:defRPr>
             </a:pPr>
             <a:r>
-              <a:t>    Валидация на 10 препаратах</a:t>
-            </a:r>
+              <a:rPr dirty="0"/>
+              <a:t>    </a:t>
+            </a:r>
+            <a:r>
+              <a:rPr dirty="0" err="1"/>
+              <a:t>Валидация</a:t>
+            </a:r>
+            <a:r>
+              <a:rPr dirty="0"/>
+              <a:t> </a:t>
+            </a:r>
+            <a:r>
+              <a:rPr dirty="0" err="1"/>
+              <a:t>на</a:t>
+            </a:r>
+            <a:r>
+              <a:rPr dirty="0"/>
+              <a:t> 10 </a:t>
+            </a:r>
+            <a:r>
+              <a:rPr dirty="0" err="1"/>
+              <a:t>препаратах</a:t>
+            </a:r>
+            <a:endParaRPr dirty="0"/>
           </a:p>
         </p:txBody>
       </p:sp>
@@ -5519,6 +5791,7 @@
           <a:lstStyle/>
           <a:p>
             <a:pPr algn="ctr"/>
+            <a:endParaRPr/>
           </a:p>
         </p:txBody>
       </p:sp>
@@ -5700,6 +5973,7 @@
           <a:lstStyle/>
           <a:p>
             <a:pPr algn="ctr"/>
+            <a:endParaRPr/>
           </a:p>
         </p:txBody>
       </p:sp>
@@ -5850,7 +6124,7 @@
 </file>
 
 <file path=ppt/slides/slide6.xml><?xml version="1.0" encoding="utf-8"?>
-<p:sld xmlns:a="http://schemas.openxmlformats.org/drawingml/2006/main" xmlns:p="http://schemas.openxmlformats.org/presentationml/2006/main" xmlns:r="http://schemas.openxmlformats.org/officeDocument/2006/relationships">
+<p:sld xmlns:a="http://schemas.openxmlformats.org/drawingml/2006/main" xmlns:r="http://schemas.openxmlformats.org/officeDocument/2006/relationships" xmlns:p="http://schemas.openxmlformats.org/presentationml/2006/main">
   <p:cSld>
     <p:bg>
       <p:bgPr>
@@ -5866,7 +6140,14 @@
         <p:cNvGrpSpPr/>
         <p:nvPr/>
       </p:nvGrpSpPr>
-      <p:grpSpPr/>
+      <p:grpSpPr>
+        <a:xfrm>
+          <a:off x="0" y="0"/>
+          <a:ext cx="0" cy="0"/>
+          <a:chOff x="0" y="0"/>
+          <a:chExt cx="0" cy="0"/>
+        </a:xfrm>
+      </p:grpSpPr>
       <p:sp>
         <p:nvSpPr>
           <p:cNvPr id="2" name="Rectangle 1"/>
@@ -5907,6 +6188,7 @@
           <a:lstStyle/>
           <a:p>
             <a:pPr algn="ctr"/>
+            <a:endParaRPr/>
           </a:p>
         </p:txBody>
       </p:sp>
@@ -5950,6 +6232,7 @@
           <a:lstStyle/>
           <a:p>
             <a:pPr algn="ctr"/>
+            <a:endParaRPr/>
           </a:p>
         </p:txBody>
       </p:sp>
@@ -6179,6 +6462,7 @@
           <a:lstStyle/>
           <a:p>
             <a:pPr algn="ctr"/>
+            <a:endParaRPr/>
           </a:p>
         </p:txBody>
       </p:sp>
@@ -6222,6 +6506,7 @@
           <a:lstStyle/>
           <a:p>
             <a:pPr algn="ctr"/>
+            <a:endParaRPr/>
           </a:p>
         </p:txBody>
       </p:sp>

</xml_diff>